<commit_message>
feat(docs): add verified manual Fabric workshop release
- add six-lab handouts, annotated screenshots and a reviewed deck
- validate the native Map and published Data Agent
- preserve student TODOs and separate solutions; retire the optional app lab

📚 - Generated by Copilot
</commit_message>
<xml_diff>
--- a/decks/out/session-2-build-it-end-to-end.pptx
+++ b/decks/out/session-2-build-it-end-to-end.pptx
@@ -2956,23 +2956,22 @@
           <a:lstStyle/>
           <a:p>
             <a:r>
-              <a:t>Judge the room. If Step 4 ran long, demo this in ten minutes and point at the folder.</a:t>
-            </a:r>
-          </a:p>
-          <a:p/>
-          <a:p>
-            <a:r>
-              <a:t>The teaching point in card three is the one that survives even as a pure demo, so make sure you</a:t>
-            </a:r>
-          </a:p>
-          <a:p>
-            <a:r>
-              <a:t>say it even if you show nothing: if your gold layer only works for the one report you happened to</a:t>
-            </a:r>
-          </a:p>
-          <a:p>
-            <a:r>
-              <a:t>build, you built a report, not a data product.</a:t>
+              <a:t>Compare the learner screenshots with the final validation and Gold table preview.</a:t>
+            </a:r>
+          </a:p>
+          <a:p>
+            <a:r>
+              <a:t>The September 17 training run produced 102 facts from 120 synthetic stands and 40 offline narratives.</a:t>
+            </a:r>
+          </a:p>
+          <a:p>
+            <a:r>
+              <a:t>The stored trusted coverage is measured over retained facts, not over all registered stands.</a:t>
+            </a:r>
+          </a:p>
+          <a:p>
+            <a:r>
+              <a:t>Do not present model-ready tables as proof that a Direct Lake report or schedule was created.</a:t>
             </a:r>
           </a:p>
         </p:txBody>
@@ -28620,14 +28619,14 @@
               </a:defRPr>
             </a:pPr>
             <a:r>
-              <a:t>STEP 4, OPTIONAL</a:t>
+              <a:t>STEP 4, CHECKPOINT</a:t>
             </a:r>
           </a:p>
         </p:txBody>
       </p:sp>
       <p:pic>
         <p:nvPicPr>
-          <p:cNvPr id="4" name="Picture 3" descr="rocket_3fc17e.png"/>
+          <p:cNvPr id="4" name="Picture 3" descr="check_3fc17e.png"/>
           <p:cNvPicPr>
             <a:picLocks noChangeAspect="1"/>
           </p:cNvPicPr>
@@ -28722,7 +28721,7 @@
               </a:defRPr>
             </a:pPr>
             <a:r>
-              <a:t>Optional: the same gold layer as a Fabric App</a:t>
+              <a:t>Review the published Gold layer</a:t>
             </a:r>
           </a:p>
         </p:txBody>
@@ -28761,7 +28760,7 @@
               </a:defRPr>
             </a:pPr>
             <a:r>
-              <a:t>Ten minute demo, or a twenty-five minute extension if Docker works everywhere and the workload is enabled.</a:t>
+              <a:t>The six notebook labs finish at Lab 05. Power BI and scheduling are separate extensions.</a:t>
             </a:r>
           </a:p>
         </p:txBody>
@@ -28872,7 +28871,7 @@
               </a:defRPr>
             </a:pPr>
             <a:r>
-              <a:t>Different audience</a:t>
+              <a:t>Coverage stays visible</a:t>
             </a:r>
           </a:p>
         </p:txBody>
@@ -28911,7 +28910,7 @@
               </a:defRPr>
             </a:pPr>
             <a:r>
-              <a:t>The Power BI report serves anyone who wants to explore. The app serves one role with fixed questions and no exploration at all.</a:t>
+              <a:t>102 classified stands out of 120 is 85 percent coverage. Keep the 18 excluded stands visible when describing the result.</a:t>
             </a:r>
           </a:p>
         </p:txBody>
@@ -29022,7 +29021,7 @@
               </a:defRPr>
             </a:pPr>
             <a:r>
-              <a:t>Chief Forester view</a:t>
+              <a:t>One fact grain</a:t>
             </a:r>
           </a:p>
         </p:txBody>
@@ -29061,7 +29060,7 @@
               </a:defRPr>
             </a:pPr>
             <a:r>
-              <a:t>Five cards, a class breakdown, a review queue and a stand detail panel. Nothing else, on purpose.</a:t>
+              <a:t>One row per stand and period. Check unique keys and matching dimensions before connecting a report.</a:t>
             </a:r>
           </a:p>
         </p:txBody>
@@ -29123,7 +29122,7 @@
           <p:nvPr/>
         </p:nvPicPr>
         <p:blipFill>
-          <a:blip r:embed="rId5"/>
+          <a:blip r:embed="rId2"/>
           <a:stretch>
             <a:fillRect/>
           </a:stretch>
@@ -29172,7 +29171,7 @@
               </a:defRPr>
             </a:pPr>
             <a:r>
-              <a:t>The teaching point</a:t>
+              <a:t>Keep the evidence</a:t>
             </a:r>
           </a:p>
         </p:txBody>
@@ -29211,7 +29210,7 @@
               </a:defRPr>
             </a:pPr>
             <a:r>
-              <a:t>A gold layer that can only feed one consumer is not really a gold layer. Same tables, second front end, no new pipeline.</a:t>
+              <a:t>Capture the table preview and final PASS output. Distinguish offline narratives from a live model response.</a:t>
             </a:r>
           </a:p>
         </p:txBody>
@@ -35330,7 +35329,7 @@
                 </a:solidFill>
                 <a:latin typeface="Segoe UI"/>
               </a:rPr>
-              <a:t>A semantic model that reads Delta directly, and a report that answers the question we started with</a:t>
+              <a:t>Model-ready Gold tables; building and verifying the Power BI report is an optional extension</a:t>
             </a:r>
           </a:p>
           <a:p>
@@ -35358,7 +35357,7 @@
                 </a:solidFill>
                 <a:latin typeface="Segoe UI"/>
               </a:rPr>
-              <a:t>A scheduled pipeline with a quality gate, which is the part that makes the rest of it real</a:t>
+              <a:t>A pipeline reference for the facilitator to validate before enabling a schedule</a:t>
             </a:r>
           </a:p>
         </p:txBody>
@@ -35445,7 +35444,7 @@
               </a:defRPr>
             </a:pPr>
             <a:r>
-              <a:t>Everything here is in the repo, runs end to end, and has been executed against a live capacity.</a:t>
+              <a:t>Verified: six solution labs, Environment preflight and output checks. Narratives used offline stubs.</a:t>
             </a:r>
           </a:p>
         </p:txBody>
@@ -36543,7 +36542,7 @@
                 </a:solidFill>
                 <a:latin typeface="Segoe UI"/>
               </a:rPr>
-              <a:t>Everything runs: notebooks, pipeline, Power BI guide and the optional Fabric App are all in the repo</a:t>
+              <a:t>Six notebook labs, the pipeline reference and the Power BI guide are in the repo</a:t>
             </a:r>
           </a:p>
           <a:p>

</xml_diff>